<commit_message>
chore(piuda): PPTX·PDF 최신 덱 반영 (14장, nav 숨김 clean)
Co-Authored-By: Claude Opus 4.8 <noreply@anthropic.com>
Claude-Session: https://claude.ai/code/session_01S8yxnUuux86mygCHFJzXQR
</commit_message>
<xml_diff>
--- a/piuda/MAJUBOM-피우다-2026.pptx
+++ b/piuda/MAJUBOM-피우다-2026.pptx
@@ -18,6 +18,7 @@
     <p:sldId id="266" r:id="rId17"/>
     <p:sldId id="267" r:id="rId18"/>
     <p:sldId id="268" r:id="rId19"/>
+    <p:sldId id="269" r:id="rId20"/>
   </p:sldIdLst>
   <p:sldSz cx="12191695" cy="6858000" type="screen4x3"/>
   <p:notesSz cx="6858000" cy="9144000"/>
@@ -3102,7 +3103,7 @@
       <p:grpSpPr/>
       <p:pic>
         <p:nvPicPr>
-          <p:cNvPr id="2" name="Picture 1" descr="p01.png"/>
+          <p:cNvPr id="2" name="Picture 1" descr="s1.png"/>
           <p:cNvPicPr>
             <a:picLocks noChangeAspect="1"/>
           </p:cNvPicPr>
@@ -3144,7 +3145,7 @@
       <p:grpSpPr/>
       <p:pic>
         <p:nvPicPr>
-          <p:cNvPr id="2" name="Picture 1" descr="p10.png"/>
+          <p:cNvPr id="2" name="Picture 1" descr="s10.png"/>
           <p:cNvPicPr>
             <a:picLocks noChangeAspect="1"/>
           </p:cNvPicPr>
@@ -3186,7 +3187,7 @@
       <p:grpSpPr/>
       <p:pic>
         <p:nvPicPr>
-          <p:cNvPr id="2" name="Picture 1" descr="p11.png"/>
+          <p:cNvPr id="2" name="Picture 1" descr="s11.png"/>
           <p:cNvPicPr>
             <a:picLocks noChangeAspect="1"/>
           </p:cNvPicPr>
@@ -3228,7 +3229,7 @@
       <p:grpSpPr/>
       <p:pic>
         <p:nvPicPr>
-          <p:cNvPr id="2" name="Picture 1" descr="p12.png"/>
+          <p:cNvPr id="2" name="Picture 1" descr="s12.png"/>
           <p:cNvPicPr>
             <a:picLocks noChangeAspect="1"/>
           </p:cNvPicPr>
@@ -3270,7 +3271,49 @@
       <p:grpSpPr/>
       <p:pic>
         <p:nvPicPr>
-          <p:cNvPr id="2" name="Picture 1" descr="p13.png"/>
+          <p:cNvPr id="2" name="Picture 1" descr="s13.png"/>
+          <p:cNvPicPr>
+            <a:picLocks noChangeAspect="1"/>
+          </p:cNvPicPr>
+          <p:nvPr/>
+        </p:nvPicPr>
+        <p:blipFill>
+          <a:blip r:embed="rId2"/>
+          <a:stretch>
+            <a:fillRect/>
+          </a:stretch>
+        </p:blipFill>
+        <p:spPr>
+          <a:xfrm>
+            <a:off x="0" y="0"/>
+            <a:ext cx="12191695" cy="6858000"/>
+          </a:xfrm>
+          <a:prstGeom prst="rect">
+            <a:avLst/>
+          </a:prstGeom>
+        </p:spPr>
+      </p:pic>
+    </p:spTree>
+  </p:cSld>
+  <p:clrMapOvr>
+    <a:masterClrMapping/>
+  </p:clrMapOvr>
+</p:sld>
+</file>
+
+<file path=ppt/slides/slide14.xml><?xml version="1.0" encoding="utf-8"?>
+<p:sld xmlns:a="http://schemas.openxmlformats.org/drawingml/2006/main" xmlns:p="http://schemas.openxmlformats.org/presentationml/2006/main" xmlns:r="http://schemas.openxmlformats.org/officeDocument/2006/relationships">
+  <p:cSld>
+    <p:spTree>
+      <p:nvGrpSpPr>
+        <p:cNvPr id="1" name=""/>
+        <p:cNvGrpSpPr/>
+        <p:nvPr/>
+      </p:nvGrpSpPr>
+      <p:grpSpPr/>
+      <p:pic>
+        <p:nvPicPr>
+          <p:cNvPr id="2" name="Picture 1" descr="s14.png"/>
           <p:cNvPicPr>
             <a:picLocks noChangeAspect="1"/>
           </p:cNvPicPr>
@@ -3312,7 +3355,7 @@
       <p:grpSpPr/>
       <p:pic>
         <p:nvPicPr>
-          <p:cNvPr id="2" name="Picture 1" descr="p02.png"/>
+          <p:cNvPr id="2" name="Picture 1" descr="s2.png"/>
           <p:cNvPicPr>
             <a:picLocks noChangeAspect="1"/>
           </p:cNvPicPr>
@@ -3354,7 +3397,7 @@
       <p:grpSpPr/>
       <p:pic>
         <p:nvPicPr>
-          <p:cNvPr id="2" name="Picture 1" descr="p03.png"/>
+          <p:cNvPr id="2" name="Picture 1" descr="s3.png"/>
           <p:cNvPicPr>
             <a:picLocks noChangeAspect="1"/>
           </p:cNvPicPr>
@@ -3396,7 +3439,7 @@
       <p:grpSpPr/>
       <p:pic>
         <p:nvPicPr>
-          <p:cNvPr id="2" name="Picture 1" descr="p04.png"/>
+          <p:cNvPr id="2" name="Picture 1" descr="s4.png"/>
           <p:cNvPicPr>
             <a:picLocks noChangeAspect="1"/>
           </p:cNvPicPr>
@@ -3438,7 +3481,7 @@
       <p:grpSpPr/>
       <p:pic>
         <p:nvPicPr>
-          <p:cNvPr id="2" name="Picture 1" descr="p05.png"/>
+          <p:cNvPr id="2" name="Picture 1" descr="s5.png"/>
           <p:cNvPicPr>
             <a:picLocks noChangeAspect="1"/>
           </p:cNvPicPr>
@@ -3480,7 +3523,7 @@
       <p:grpSpPr/>
       <p:pic>
         <p:nvPicPr>
-          <p:cNvPr id="2" name="Picture 1" descr="p06.png"/>
+          <p:cNvPr id="2" name="Picture 1" descr="s6.png"/>
           <p:cNvPicPr>
             <a:picLocks noChangeAspect="1"/>
           </p:cNvPicPr>
@@ -3522,7 +3565,7 @@
       <p:grpSpPr/>
       <p:pic>
         <p:nvPicPr>
-          <p:cNvPr id="2" name="Picture 1" descr="p07.png"/>
+          <p:cNvPr id="2" name="Picture 1" descr="s7.png"/>
           <p:cNvPicPr>
             <a:picLocks noChangeAspect="1"/>
           </p:cNvPicPr>
@@ -3564,7 +3607,7 @@
       <p:grpSpPr/>
       <p:pic>
         <p:nvPicPr>
-          <p:cNvPr id="2" name="Picture 1" descr="p08.png"/>
+          <p:cNvPr id="2" name="Picture 1" descr="s8.png"/>
           <p:cNvPicPr>
             <a:picLocks noChangeAspect="1"/>
           </p:cNvPicPr>
@@ -3606,7 +3649,7 @@
       <p:grpSpPr/>
       <p:pic>
         <p:nvPicPr>
-          <p:cNvPr id="2" name="Picture 1" descr="p09.png"/>
+          <p:cNvPr id="2" name="Picture 1" descr="s9.png"/>
           <p:cNvPicPr>
             <a:picLocks noChangeAspect="1"/>
           </p:cNvPicPr>

</xml_diff>